<commit_message>
Second terminology pass, and keep the words that earn their place
Scanned the artifacts again for words that name something without
showing what it is: 디스패치, 코퍼스, 시그니처, 트레이드오프, 인젝션,
파서, 스캐너, 커버리지, 회귀 측정, 과적합. All replaced. 라운드 became
회차, which is the same idea in Korean and reads as a count rather than
a boxing metaphor.

Left alone deliberately: 파이프라인, 프롬프트, 포팅, 벤치마크, 위임,
정적 검증, 자기 수정, 임시 사본. These either carry in ordinary business
use or are this project's defined vocabulary, and swapping them would
cost precision without buying clarity.

BLOCKER/WARNING/PASS stay in English because they are literal tool
output - the 판정 체계 table gives the Korean reading once, and the logs
in the demo have to match what the console actually prints. That is
also why the console strings changed alongside the documents again;
the run now says 병렬 배분 and 회차 rather than fan-out and 라운드.

Co-Authored-By: Claude Opus 5 <noreply@anthropic.com>
</commit_message>
<xml_diff>
--- a/docs/weekly/assets/최종발표장표.pptx
+++ b/docs/weekly/assets/최종발표장표.pptx
@@ -1950,7 +1950,7 @@
                 </a:solidFill>
                 <a:latin typeface="Arial"/>
               </a:rPr>
-              <a:t>Repairer  자기 수정, 라운드 상한 2</a:t>
+              <a:t>Repairer  자기 수정, 회차 상한 2</a:t>
             </a:r>
           </a:p>
           <a:p>
@@ -4379,7 +4379,7 @@
                 </a:solidFill>
                 <a:latin typeface="Arial"/>
               </a:rPr>
-              <a:t>시그니처 → 클래스</a:t>
+              <a:t>선언부 → 클래스</a:t>
             </a:r>
           </a:p>
         </p:txBody>
@@ -4804,7 +4804,7 @@
                 </a:solidFill>
                 <a:latin typeface="Arial"/>
               </a:rPr>
-              <a:t>⑤ 자기 수정은 ④ 검증 실패 시에만 ③으로 되돌린다 (라운드 상한 2)</a:t>
+              <a:t>⑤ 자기 수정은 ④ 검증 실패 시에만 ③으로 되돌린다 (회차 상한 2)</a:t>
             </a:r>
           </a:p>
         </p:txBody>

</xml_diff>

<commit_message>
Name the repair loop Validator-driven Self-Correction
자기 수정 was doing two jobs: naming the mechanism and hiding what makes
it different. The scoring guide asks for Self-Correction by name, and
what distinguishes ours is that the scorer is a deterministic validator
rather than the model grading its own branches - so the full name says
both.

Full form where the technique is introduced (the technology choice on
slide 2, the pipeline stage, the feature definition), 자가 교정 in
running text. Defining once and shortening after is the normal rule.

자가 rather than 자기, which reads like 자가진단 and does not snag.

Co-Authored-By: Claude Opus 5 <noreply@anthropic.com>
</commit_message>
<xml_diff>
--- a/docs/weekly/assets/최종발표장표.pptx
+++ b/docs/weekly/assets/최종발표장표.pptx
@@ -1950,7 +1950,7 @@
                 </a:solidFill>
                 <a:latin typeface="Arial"/>
               </a:rPr>
-              <a:t>Repairer  자기 수정, 회차 상한 2</a:t>
+              <a:t>Repairer  검증 기반 자가 교정, 회차 상한 2</a:t>
             </a:r>
           </a:p>
           <a:p>
@@ -3443,7 +3443,7 @@
                 </a:solidFill>
                 <a:latin typeface="Arial"/>
               </a:rPr>
-              <a:t>Tree-of-Thoughts + Self-Correction</a:t>
+              <a:t>Tree-of-Thoughts + Validator-driven Self-Correction</a:t>
             </a:r>
             <a:endParaRPr lang="en-US" sz="950" dirty="0"/>
           </a:p>
@@ -4804,7 +4804,7 @@
                 </a:solidFill>
                 <a:latin typeface="Arial"/>
               </a:rPr>
-              <a:t>⑤ 자기 수정은 ④ 검증 실패 시에만 ③으로 되돌린다 (회차 상한 2)</a:t>
+              <a:t>⑤ 검증 기반 자가 교정은 ④ 검증 실패 시에만 ③으로 되돌린다 (회차 상한 2)</a:t>
             </a:r>
           </a:p>
         </p:txBody>

</xml_diff>